<commit_message>
melhora da area do cotista
</commit_message>
<xml_diff>
--- a/prospecção/abordagem/Argus_OnePager_Banco.pptx
+++ b/prospecção/abordagem/Argus_OnePager_Banco.pptx
@@ -3142,7 +3142,7 @@
       </p:sp>
       <p:pic>
         <p:nvPicPr>
-          <p:cNvPr id="3" name="Picture 2" descr="favicon_argus.png"/>
+          <p:cNvPr id="3" name="Picture 2" descr="logo_argus_branca.png"/>
           <p:cNvPicPr>
             <a:picLocks noChangeAspect="1"/>
           </p:cNvPicPr>
@@ -3156,8 +3156,8 @@
         </p:blipFill>
         <p:spPr>
           <a:xfrm>
-            <a:off x="667512" y="667512"/>
-            <a:ext cx="457200" cy="457200"/>
+            <a:off x="640080" y="566928"/>
+            <a:ext cx="1864852" cy="566928"/>
           </a:xfrm>
           <a:prstGeom prst="rect">
             <a:avLst/>
@@ -3172,8 +3172,8 @@
         </p:nvSpPr>
         <p:spPr>
           <a:xfrm>
-            <a:off x="1207007" y="658368"/>
-            <a:ext cx="3657600" cy="365760"/>
+            <a:off x="658368" y="1225296"/>
+            <a:ext cx="5486400" cy="274320"/>
           </a:xfrm>
           <a:prstGeom prst="rect">
             <a:avLst/>
@@ -3198,27 +3198,73 @@
               </a:spcAft>
             </a:pPr>
             <a:r>
-              <a:rPr sz="2000" b="1" i="0" spc="50">
+              <a:rPr sz="750" b="0" i="0" spc="150">
+                <a:solidFill>
+                  <a:srgbClr val="A8B6C6"/>
+                </a:solidFill>
+                <a:latin typeface="Consolas"/>
+              </a:rPr>
+              <a:t>ADMINISTRAÇÃO FIDUCIÁRIA E CUSTÓDIA DE FUNDOS</a:t>
+            </a:r>
+          </a:p>
+        </p:txBody>
+      </p:sp>
+      <p:sp>
+        <p:nvSpPr>
+          <p:cNvPr id="5" name="TextBox 4"/>
+          <p:cNvSpPr txBox="1"/>
+          <p:nvPr/>
+        </p:nvSpPr>
+        <p:spPr>
+          <a:xfrm>
+            <a:off x="640080" y="1536192"/>
+            <a:ext cx="6281927" cy="822960"/>
+          </a:xfrm>
+          <a:prstGeom prst="rect">
+            <a:avLst/>
+          </a:prstGeom>
+          <a:noFill/>
+        </p:spPr>
+        <p:txBody>
+          <a:bodyPr wrap="square" lIns="0" rIns="0" tIns="0" bIns="0" anchor="t">
+            <a:spAutoFit/>
+          </a:bodyPr>
+          <a:lstStyle/>
+          <a:p>
+            <a:pPr algn="l">
+              <a:lnSpc>
+                <a:spcPct val="106000"/>
+              </a:lnSpc>
+              <a:spcBef>
+                <a:spcPts val="0"/>
+              </a:spcBef>
+              <a:spcAft>
+                <a:spcPts val="0"/>
+              </a:spcAft>
+            </a:pPr>
+            <a:r>
+              <a:rPr sz="2100" b="0" i="0">
                 <a:solidFill>
                   <a:srgbClr val="F3F6FA"/>
                 </a:solidFill>
                 <a:latin typeface="Georgia"/>
               </a:rPr>
-              <a:t>ARGUS</a:t>
-            </a:r>
-          </a:p>
-        </p:txBody>
-      </p:sp>
-      <p:sp>
-        <p:nvSpPr>
-          <p:cNvPr id="5" name="TextBox 4"/>
+              <a:t>Uma nova linha de receita recorrente
+para o seu banco.</a:t>
+            </a:r>
+          </a:p>
+        </p:txBody>
+      </p:sp>
+      <p:sp>
+        <p:nvSpPr>
+          <p:cNvPr id="6" name="TextBox 5"/>
           <p:cNvSpPr txBox="1"/>
           <p:nvPr/>
         </p:nvSpPr>
         <p:spPr>
           <a:xfrm>
-            <a:off x="1225295" y="1097280"/>
-            <a:ext cx="5486400" cy="274320"/>
+            <a:off x="640080" y="2212848"/>
+            <a:ext cx="6281927" cy="274320"/>
           </a:xfrm>
           <a:prstGeom prst="rect">
             <a:avLst/>
@@ -3243,97 +3289,6 @@
               </a:spcAft>
             </a:pPr>
             <a:r>
-              <a:rPr sz="750" b="0" i="0" spc="150">
-                <a:solidFill>
-                  <a:srgbClr val="A8B6C6"/>
-                </a:solidFill>
-                <a:latin typeface="Consolas"/>
-              </a:rPr>
-              <a:t>ADMINISTRAÇÃO FIDUCIÁRIA E CUSTÓDIA DE FUNDOS</a:t>
-            </a:r>
-          </a:p>
-        </p:txBody>
-      </p:sp>
-      <p:sp>
-        <p:nvSpPr>
-          <p:cNvPr id="6" name="TextBox 5"/>
-          <p:cNvSpPr txBox="1"/>
-          <p:nvPr/>
-        </p:nvSpPr>
-        <p:spPr>
-          <a:xfrm>
-            <a:off x="640080" y="1536192"/>
-            <a:ext cx="6281927" cy="822960"/>
-          </a:xfrm>
-          <a:prstGeom prst="rect">
-            <a:avLst/>
-          </a:prstGeom>
-          <a:noFill/>
-        </p:spPr>
-        <p:txBody>
-          <a:bodyPr wrap="square" lIns="0" rIns="0" tIns="0" bIns="0" anchor="t">
-            <a:spAutoFit/>
-          </a:bodyPr>
-          <a:lstStyle/>
-          <a:p>
-            <a:pPr algn="l">
-              <a:lnSpc>
-                <a:spcPct val="106000"/>
-              </a:lnSpc>
-              <a:spcBef>
-                <a:spcPts val="0"/>
-              </a:spcBef>
-              <a:spcAft>
-                <a:spcPts val="0"/>
-              </a:spcAft>
-            </a:pPr>
-            <a:r>
-              <a:rPr sz="2100" b="0" i="0">
-                <a:solidFill>
-                  <a:srgbClr val="F3F6FA"/>
-                </a:solidFill>
-                <a:latin typeface="Georgia"/>
-              </a:rPr>
-              <a:t>Uma nova linha de receita recorrente
-para o seu banco.</a:t>
-            </a:r>
-          </a:p>
-        </p:txBody>
-      </p:sp>
-      <p:sp>
-        <p:nvSpPr>
-          <p:cNvPr id="7" name="TextBox 6"/>
-          <p:cNvSpPr txBox="1"/>
-          <p:nvPr/>
-        </p:nvSpPr>
-        <p:spPr>
-          <a:xfrm>
-            <a:off x="640080" y="2212848"/>
-            <a:ext cx="6281927" cy="274320"/>
-          </a:xfrm>
-          <a:prstGeom prst="rect">
-            <a:avLst/>
-          </a:prstGeom>
-          <a:noFill/>
-        </p:spPr>
-        <p:txBody>
-          <a:bodyPr wrap="square" lIns="0" rIns="0" tIns="0" bIns="0" anchor="t">
-            <a:spAutoFit/>
-          </a:bodyPr>
-          <a:lstStyle/>
-          <a:p>
-            <a:pPr algn="l">
-              <a:lnSpc>
-                <a:spcPct val="100000"/>
-              </a:lnSpc>
-              <a:spcBef>
-                <a:spcPts val="0"/>
-              </a:spcBef>
-              <a:spcAft>
-                <a:spcPts val="0"/>
-              </a:spcAft>
-            </a:pPr>
-            <a:r>
               <a:rPr sz="1000" b="0" i="1">
                 <a:solidFill>
                   <a:srgbClr val="1FC0EF"/>
@@ -3347,7 +3302,7 @@
       </p:sp>
       <p:cxnSp>
         <p:nvCxnSpPr>
-          <p:cNvPr id="8" name="Connector 7"/>
+          <p:cNvPr id="7" name="Connector 6"/>
           <p:cNvCxnSpPr/>
           <p:nvPr/>
         </p:nvCxnSpPr>
@@ -3383,7 +3338,7 @@
       </p:cxnSp>
       <p:sp>
         <p:nvSpPr>
-          <p:cNvPr id="9" name="TextBox 8"/>
+          <p:cNvPr id="8" name="TextBox 7"/>
           <p:cNvSpPr txBox="1"/>
           <p:nvPr/>
         </p:nvSpPr>
@@ -3428,7 +3383,7 @@
       </p:sp>
       <p:sp>
         <p:nvSpPr>
-          <p:cNvPr id="10" name="TextBox 9"/>
+          <p:cNvPr id="9" name="TextBox 8"/>
           <p:cNvSpPr txBox="1"/>
           <p:nvPr/>
         </p:nvSpPr>
@@ -3473,7 +3428,7 @@
       </p:sp>
       <p:cxnSp>
         <p:nvCxnSpPr>
-          <p:cNvPr id="11" name="Connector 10"/>
+          <p:cNvPr id="10" name="Connector 9"/>
           <p:cNvCxnSpPr/>
           <p:nvPr/>
         </p:nvCxnSpPr>
@@ -3509,7 +3464,7 @@
       </p:cxnSp>
       <p:sp>
         <p:nvSpPr>
-          <p:cNvPr id="12" name="TextBox 11"/>
+          <p:cNvPr id="11" name="TextBox 10"/>
           <p:cNvSpPr txBox="1"/>
           <p:nvPr/>
         </p:nvSpPr>
@@ -3554,7 +3509,7 @@
       </p:sp>
       <p:sp>
         <p:nvSpPr>
-          <p:cNvPr id="13" name="Oval 12"/>
+          <p:cNvPr id="12" name="Oval 11"/>
           <p:cNvSpPr/>
           <p:nvPr/>
         </p:nvSpPr>
@@ -3598,7 +3553,7 @@
       </p:sp>
       <p:sp>
         <p:nvSpPr>
-          <p:cNvPr id="14" name="TextBox 13"/>
+          <p:cNvPr id="13" name="TextBox 12"/>
           <p:cNvSpPr txBox="1"/>
           <p:nvPr/>
         </p:nvSpPr>
@@ -3643,7 +3598,7 @@
       </p:sp>
       <p:sp>
         <p:nvSpPr>
-          <p:cNvPr id="15" name="Oval 14"/>
+          <p:cNvPr id="14" name="Oval 13"/>
           <p:cNvSpPr/>
           <p:nvPr/>
         </p:nvSpPr>
@@ -3687,7 +3642,7 @@
       </p:sp>
       <p:sp>
         <p:nvSpPr>
-          <p:cNvPr id="16" name="TextBox 15"/>
+          <p:cNvPr id="15" name="TextBox 14"/>
           <p:cNvSpPr txBox="1"/>
           <p:nvPr/>
         </p:nvSpPr>
@@ -3732,7 +3687,7 @@
       </p:sp>
       <p:sp>
         <p:nvSpPr>
-          <p:cNvPr id="17" name="Oval 16"/>
+          <p:cNvPr id="16" name="Oval 15"/>
           <p:cNvSpPr/>
           <p:nvPr/>
         </p:nvSpPr>
@@ -3776,7 +3731,7 @@
       </p:sp>
       <p:sp>
         <p:nvSpPr>
-          <p:cNvPr id="18" name="TextBox 17"/>
+          <p:cNvPr id="17" name="TextBox 16"/>
           <p:cNvSpPr txBox="1"/>
           <p:nvPr/>
         </p:nvSpPr>
@@ -3821,7 +3776,7 @@
       </p:sp>
       <p:sp>
         <p:nvSpPr>
-          <p:cNvPr id="19" name="Oval 18"/>
+          <p:cNvPr id="18" name="Oval 17"/>
           <p:cNvSpPr/>
           <p:nvPr/>
         </p:nvSpPr>
@@ -3865,7 +3820,7 @@
       </p:sp>
       <p:sp>
         <p:nvSpPr>
-          <p:cNvPr id="20" name="TextBox 19"/>
+          <p:cNvPr id="19" name="TextBox 18"/>
           <p:cNvSpPr txBox="1"/>
           <p:nvPr/>
         </p:nvSpPr>
@@ -3910,7 +3865,7 @@
       </p:sp>
       <p:sp>
         <p:nvSpPr>
-          <p:cNvPr id="21" name="Rounded Rectangle 20"/>
+          <p:cNvPr id="20" name="Rounded Rectangle 19"/>
           <p:cNvSpPr/>
           <p:nvPr/>
         </p:nvSpPr>
@@ -3958,7 +3913,7 @@
       </p:sp>
       <p:sp>
         <p:nvSpPr>
-          <p:cNvPr id="22" name="TextBox 21"/>
+          <p:cNvPr id="21" name="TextBox 20"/>
           <p:cNvSpPr txBox="1"/>
           <p:nvPr/>
         </p:nvSpPr>
@@ -4003,7 +3958,7 @@
       </p:sp>
       <p:sp>
         <p:nvSpPr>
-          <p:cNvPr id="23" name="TextBox 22"/>
+          <p:cNvPr id="22" name="TextBox 21"/>
           <p:cNvSpPr txBox="1"/>
           <p:nvPr/>
         </p:nvSpPr>
@@ -4048,7 +4003,7 @@
       </p:sp>
       <p:cxnSp>
         <p:nvCxnSpPr>
-          <p:cNvPr id="24" name="Connector 23"/>
+          <p:cNvPr id="23" name="Connector 22"/>
           <p:cNvCxnSpPr/>
           <p:nvPr/>
         </p:nvCxnSpPr>
@@ -4084,7 +4039,7 @@
       </p:cxnSp>
       <p:sp>
         <p:nvSpPr>
-          <p:cNvPr id="25" name="TextBox 24"/>
+          <p:cNvPr id="24" name="TextBox 23"/>
           <p:cNvSpPr txBox="1"/>
           <p:nvPr/>
         </p:nvSpPr>
@@ -4129,7 +4084,7 @@
       </p:sp>
       <p:sp>
         <p:nvSpPr>
-          <p:cNvPr id="26" name="TextBox 25"/>
+          <p:cNvPr id="25" name="TextBox 24"/>
           <p:cNvSpPr txBox="1"/>
           <p:nvPr/>
         </p:nvSpPr>
@@ -4174,7 +4129,7 @@
       </p:sp>
       <p:sp>
         <p:nvSpPr>
-          <p:cNvPr id="27" name="Rounded Rectangle 26"/>
+          <p:cNvPr id="26" name="Rounded Rectangle 25"/>
           <p:cNvSpPr/>
           <p:nvPr/>
         </p:nvSpPr>
@@ -4220,7 +4175,7 @@
       </p:sp>
       <p:sp>
         <p:nvSpPr>
-          <p:cNvPr id="28" name="TextBox 27"/>
+          <p:cNvPr id="27" name="TextBox 26"/>
           <p:cNvSpPr txBox="1"/>
           <p:nvPr/>
         </p:nvSpPr>
@@ -4265,7 +4220,7 @@
       </p:sp>
       <p:sp>
         <p:nvSpPr>
-          <p:cNvPr id="29" name="TextBox 28"/>
+          <p:cNvPr id="28" name="TextBox 27"/>
           <p:cNvSpPr txBox="1"/>
           <p:nvPr/>
         </p:nvSpPr>
@@ -4310,7 +4265,7 @@
       </p:sp>
       <p:sp>
         <p:nvSpPr>
-          <p:cNvPr id="30" name="TextBox 29"/>
+          <p:cNvPr id="29" name="TextBox 28"/>
           <p:cNvSpPr txBox="1"/>
           <p:nvPr/>
         </p:nvSpPr>
@@ -4399,14 +4354,14 @@
       </p:sp>
       <p:sp>
         <p:nvSpPr>
-          <p:cNvPr id="31" name="Rounded Rectangle 30"/>
+          <p:cNvPr id="30" name="Rounded Rectangle 29"/>
           <p:cNvSpPr/>
           <p:nvPr/>
         </p:nvSpPr>
         <p:spPr>
           <a:xfrm>
-            <a:off x="640080" y="9729216"/>
-            <a:ext cx="6281927" cy="402336"/>
+            <a:off x="640080" y="9656064"/>
+            <a:ext cx="6281927" cy="512064"/>
           </a:xfrm>
           <a:prstGeom prst="roundRect">
             <a:avLst>
@@ -4447,14 +4402,14 @@
       </p:sp>
       <p:sp>
         <p:nvSpPr>
-          <p:cNvPr id="32" name="TextBox 31"/>
+          <p:cNvPr id="31" name="TextBox 30"/>
           <p:cNvSpPr txBox="1"/>
           <p:nvPr/>
         </p:nvSpPr>
         <p:spPr>
           <a:xfrm>
-            <a:off x="896112" y="9838944"/>
-            <a:ext cx="5769863" cy="274320"/>
+            <a:off x="896112" y="9756648"/>
+            <a:ext cx="5769863" cy="329184"/>
           </a:xfrm>
           <a:prstGeom prst="rect">
             <a:avLst/>
@@ -4469,7 +4424,7 @@
           <a:p>
             <a:pPr algn="l">
               <a:lnSpc>
-                <a:spcPct val="100000"/>
+                <a:spcPct val="112000"/>
               </a:lnSpc>
               <a:spcBef>
                 <a:spcPts val="0"/>
@@ -4479,35 +4434,26 @@
               </a:spcAft>
             </a:pPr>
             <a:r>
-              <a:rPr sz="900" b="1" i="0" spc="120">
-                <a:solidFill>
-                  <a:srgbClr val="6A50AC"/>
-                </a:solidFill>
-                <a:latin typeface="Consolas"/>
-              </a:rPr>
-              <a:t>PRÓXIMO PASSO   </a:t>
-            </a:r>
-            <a:r>
-              <a:rPr sz="1050" b="0" i="0">
+              <a:rPr sz="1050" b="0" i="1">
                 <a:solidFill>
                   <a:srgbClr val="2B3232"/>
                 </a:solidFill>
-                <a:latin typeface="Calibri"/>
+                <a:latin typeface="Georgia"/>
               </a:rPr>
-              <a:t>20 minutos, sem compromisso — basta responder o e-mail.</a:t>
+              <a:t>Queremos apresentar a conta exata para o seu banco — 20 minutos com quem construiu a plataforma. É só responder o e-mail que trouxe esta página.</a:t>
             </a:r>
           </a:p>
         </p:txBody>
       </p:sp>
       <p:cxnSp>
         <p:nvCxnSpPr>
-          <p:cNvPr id="33" name="Connector 32"/>
+          <p:cNvPr id="32" name="Connector 31"/>
           <p:cNvCxnSpPr/>
           <p:nvPr/>
         </p:nvCxnSpPr>
         <p:spPr>
           <a:xfrm>
-            <a:off x="640080" y="10122408"/>
+            <a:off x="640080" y="10232136"/>
             <a:ext cx="6281927" cy="0"/>
           </a:xfrm>
           <a:prstGeom prst="line">
@@ -4537,13 +4483,13 @@
       </p:cxnSp>
       <p:sp>
         <p:nvSpPr>
-          <p:cNvPr id="34" name="TextBox 33"/>
+          <p:cNvPr id="33" name="TextBox 32"/>
           <p:cNvSpPr txBox="1"/>
           <p:nvPr/>
         </p:nvSpPr>
         <p:spPr>
           <a:xfrm>
-            <a:off x="640080" y="10232136"/>
+            <a:off x="640080" y="10341863"/>
             <a:ext cx="3840480" cy="228600"/>
           </a:xfrm>
           <a:prstGeom prst="rect">
@@ -4582,13 +4528,13 @@
       </p:sp>
       <p:sp>
         <p:nvSpPr>
-          <p:cNvPr id="35" name="TextBox 34"/>
+          <p:cNvPr id="34" name="TextBox 33"/>
           <p:cNvSpPr txBox="1"/>
           <p:nvPr/>
         </p:nvSpPr>
         <p:spPr>
           <a:xfrm>
-            <a:off x="4270248" y="10232136"/>
+            <a:off x="4270248" y="10341863"/>
             <a:ext cx="2651760" cy="228600"/>
           </a:xfrm>
           <a:prstGeom prst="rect">

</xml_diff>